<commit_message>
Slides: badged PPTX of sd-08-001
</commit_message>
<xml_diff>
--- a/system-design-101/vi/lessons/sd-08-001/slides/sd-08-001.pptx
+++ b/system-design-101/vi/lessons/sd-08-001/slides/sd-08-001.pptx
@@ -6573,15 +6573,37 @@
               <a:buChar char="•"/>
             </a:pPr>
             <a:r>
-              <a:rPr lang="en-US" sz="2400" dirty="0" spc="10" kern="0">
-                <a:solidFill>
-                  <a:srgbClr val="14161C"/>
-                </a:solidFill>
-                <a:latin typeface="Be Vietnam Pro" pitchFamily="34" charset="0"/>
-                <a:ea typeface="Be Vietnam Pro" pitchFamily="34" charset="-122"/>
-                <a:cs typeface="Be Vietnam Pro" pitchFamily="34" charset="-120"/>
-              </a:rPr>
-              <a:t>Chứa</a:t>
+              <a:rPr lang="en-US" sz="2400" dirty="0" spc="-1" kern="0">
+                <a:solidFill>
+                  <a:srgbClr val="14161C"/>
+                </a:solidFill>
+                <a:latin typeface="Be Vietnam Pro" pitchFamily="34" charset="0"/>
+                <a:ea typeface="Be Vietnam Pro" pitchFamily="34" charset="-122"/>
+                <a:cs typeface="Be Vietnam Pro" pitchFamily="34" charset="-120"/>
+              </a:rPr>
+              <a:t>Mặc</a:t>
+            </a:r>
+            <a:r>
+              <a:rPr lang="en-US" sz="2400" dirty="0" spc="20" kern="0">
+                <a:solidFill>
+                  <a:srgbClr val="14161C"/>
+                </a:solidFill>
+                <a:latin typeface="Be Vietnam Pro" pitchFamily="34" charset="0"/>
+                <a:ea typeface="Be Vietnam Pro" pitchFamily="34" charset="-122"/>
+                <a:cs typeface="Be Vietnam Pro" pitchFamily="34" charset="-120"/>
+              </a:rPr>
+              <a:t> định</a:t>
+            </a:r>
+            <a:r>
+              <a:rPr lang="en-US" sz="2400" dirty="0" spc="8" kern="0">
+                <a:solidFill>
+                  <a:srgbClr val="14161C"/>
+                </a:solidFill>
+                <a:latin typeface="Be Vietnam Pro" pitchFamily="34" charset="0"/>
+                <a:ea typeface="Be Vietnam Pro" pitchFamily="34" charset="-122"/>
+                <a:cs typeface="Be Vietnam Pro" pitchFamily="34" charset="-120"/>
+              </a:rPr>
+              <a:t> chứa</a:t>
             </a:r>
             <a:r>
               <a:rPr lang="en-US" sz="2400" dirty="0" spc="-3" kern="0">
@@ -14109,6 +14131,17 @@
                         <a:t> cờ</a:t>
                       </a:r>
                       <a:r>
+                        <a:rPr lang="en-US" sz="2250" dirty="0" spc="1" kern="0">
+                          <a:solidFill>
+                            <a:srgbClr val="1F3FD1"/>
+                          </a:solidFill>
+                          <a:latin typeface="Be Vietnam Pro ExtraBold" pitchFamily="34" charset="0"/>
+                          <a:ea typeface="Be Vietnam Pro ExtraBold" pitchFamily="34" charset="-122"/>
+                          <a:cs typeface="Be Vietnam Pro ExtraBold" pitchFamily="34" charset="-120"/>
+                        </a:rPr>
+                        <a:t> +</a:t>
+                      </a:r>
+                      <a:r>
                         <a:rPr lang="en-US" sz="2250" dirty="0" spc="-3" kern="0">
                           <a:solidFill>
                             <a:srgbClr val="1F3FD1"/>
@@ -14117,18 +14150,7 @@
                           <a:ea typeface="Be Vietnam Pro ExtraBold" pitchFamily="34" charset="-122"/>
                           <a:cs typeface="Be Vietnam Pro ExtraBold" pitchFamily="34" charset="-120"/>
                         </a:rPr>
-                        <a:t> liên</a:t>
-                      </a:r>
-                      <a:r>
-                        <a:rPr lang="en-US" sz="2250" dirty="0" spc="3" kern="0">
-                          <a:solidFill>
-                            <a:srgbClr val="1F3FD1"/>
-                          </a:solidFill>
-                          <a:latin typeface="Be Vietnam Pro ExtraBold" pitchFamily="34" charset="0"/>
-                          <a:ea typeface="Be Vietnam Pro ExtraBold" pitchFamily="34" charset="-122"/>
-                          <a:cs typeface="Be Vietnam Pro ExtraBold" pitchFamily="34" charset="-120"/>
-                        </a:rPr>
-                        <a:t> tục</a:t>
+                        <a:t> sched_yield</a:t>
                       </a:r>
                       <a:endParaRPr lang="en-US" sz="1200" dirty="0"/>
                     </a:p>
@@ -14175,7 +14197,7 @@
                         <a:buNone/>
                       </a:pPr>
                       <a:r>
-                        <a:rPr lang="en-US" sz="2250" dirty="0" spc="2" kern="0">
+                        <a:rPr lang="en-US" sz="2250" dirty="0" spc="0" kern="0">
                           <a:solidFill>
                             <a:srgbClr val="000000"/>
                           </a:solidFill>
@@ -14183,7 +14205,29 @@
                           <a:ea typeface="Be Vietnam Pro ExtraBold" pitchFamily="34" charset="-122"/>
                           <a:cs typeface="Be Vietnam Pro ExtraBold" pitchFamily="34" charset="-120"/>
                         </a:rPr>
-                        <a:t>0,4</a:t>
+                        <a:t>0,3</a:t>
+                      </a:r>
+                      <a:r>
+                        <a:rPr lang="en-US" sz="2250" dirty="0" spc="-2" kern="0">
+                          <a:solidFill>
+                            <a:srgbClr val="000000"/>
+                          </a:solidFill>
+                          <a:latin typeface="Be Vietnam Pro ExtraBold" pitchFamily="34" charset="0"/>
+                          <a:ea typeface="Be Vietnam Pro ExtraBold" pitchFamily="34" charset="-122"/>
+                          <a:cs typeface="Be Vietnam Pro ExtraBold" pitchFamily="34" charset="-120"/>
+                        </a:rPr>
+                        <a:t> đến</a:t>
+                      </a:r>
+                      <a:r>
+                        <a:rPr lang="en-US" sz="2250" dirty="0" spc="3" kern="0">
+                          <a:solidFill>
+                            <a:srgbClr val="000000"/>
+                          </a:solidFill>
+                          <a:latin typeface="Be Vietnam Pro ExtraBold" pitchFamily="34" charset="0"/>
+                          <a:ea typeface="Be Vietnam Pro ExtraBold" pitchFamily="34" charset="-122"/>
+                          <a:cs typeface="Be Vietnam Pro ExtraBold" pitchFamily="34" charset="-120"/>
+                        </a:rPr>
+                        <a:t> 0,4</a:t>
                       </a:r>
                       <a:endParaRPr lang="en-US" sz="1200" dirty="0"/>
                     </a:p>
@@ -14260,7 +14304,7 @@
                           <a:ea typeface="Be Vietnam Pro ExtraBold" pitchFamily="34" charset="-122"/>
                           <a:cs typeface="Be Vietnam Pro ExtraBold" pitchFamily="34" charset="-120"/>
                         </a:rPr>
-                        <a:t> 2,0</a:t>
+                        <a:t> 2,2</a:t>
                       </a:r>
                       <a:endParaRPr lang="en-US" sz="1200" dirty="0"/>
                     </a:p>
@@ -14364,10 +14408,10 @@
                 <a:ea typeface="Be Vietnam Pro SemiBold" pitchFamily="34" charset="-122"/>
                 <a:cs typeface="Be Vietnam Pro SemiBold" pitchFamily="34" charset="-120"/>
               </a:rPr>
-              <a:t>Nhanh</a:t>
-            </a:r>
-            <a:r>
-              <a:rPr lang="en-US" sz="2550" dirty="0" spc="-2" kern="0">
+              <a:t>Nhìn</a:t>
+            </a:r>
+            <a:r>
+              <a:rPr lang="en-US" sz="2550" dirty="0" spc="-3" kern="0">
                 <a:solidFill>
                   <a:srgbClr val="14161C"/>
                 </a:solidFill>
@@ -14375,7 +14419,7 @@
                 <a:ea typeface="Be Vietnam Pro SemiBold" pitchFamily="34" charset="-122"/>
                 <a:cs typeface="Be Vietnam Pro SemiBold" pitchFamily="34" charset="-120"/>
               </a:rPr>
-              <a:t> hơn</a:t>
+              <a:t> cờ</a:t>
             </a:r>
             <a:r>
               <a:rPr lang="en-US" sz="2550" dirty="0" spc="0" kern="0">
@@ -14386,10 +14430,10 @@
                 <a:ea typeface="Be Vietnam Pro SemiBold" pitchFamily="34" charset="-122"/>
                 <a:cs typeface="Be Vietnam Pro SemiBold" pitchFamily="34" charset="-120"/>
               </a:rPr>
-              <a:t> hẳn</a:t>
-            </a:r>
-            <a:r>
-              <a:rPr lang="en-US" sz="2550" dirty="0" spc="2" kern="0">
+              <a:t> thuần:</a:t>
+            </a:r>
+            <a:r>
+              <a:rPr lang="en-US" sz="2550" dirty="0" spc="-1" kern="0">
                 <a:solidFill>
                   <a:srgbClr val="14161C"/>
                 </a:solidFill>
@@ -14397,10 +14441,10 @@
                 <a:ea typeface="Be Vietnam Pro SemiBold" pitchFamily="34" charset="-122"/>
                 <a:cs typeface="Be Vietnam Pro SemiBold" pitchFamily="34" charset="-120"/>
               </a:rPr>
-              <a:t> chỉ khi</a:t>
-            </a:r>
-            <a:r>
-              <a:rPr lang="en-US" sz="2550" dirty="0" spc="-3" kern="0">
+              <a:t> 0,13</a:t>
+            </a:r>
+            <a:r>
+              <a:rPr lang="en-US" sz="2550" dirty="0" spc="-2" kern="0">
                 <a:solidFill>
                   <a:srgbClr val="14161C"/>
                 </a:solidFill>
@@ -14408,7 +14452,7 @@
                 <a:ea typeface="Be Vietnam Pro SemiBold" pitchFamily="34" charset="-122"/>
                 <a:cs typeface="Be Vietnam Pro SemiBold" pitchFamily="34" charset="-120"/>
               </a:rPr>
-              <a:t> không</a:t>
+              <a:t> µs ở</a:t>
             </a:r>
             <a:r>
               <a:rPr lang="en-US" sz="2550" dirty="0" spc="0" kern="0">
@@ -14419,10 +14463,10 @@
                 <a:ea typeface="Be Vietnam Pro SemiBold" pitchFamily="34" charset="-122"/>
                 <a:cs typeface="Be Vietnam Pro SemiBold" pitchFamily="34" charset="-120"/>
               </a:rPr>
-              <a:t> ngủ:</a:t>
-            </a:r>
-            <a:r>
-              <a:rPr lang="en-US" sz="2550" dirty="0" spc="2" kern="0">
+              <a:t> hai</a:t>
+            </a:r>
+            <a:r>
+              <a:rPr lang="en-US" sz="2550" dirty="0" spc="-4" kern="0">
                 <a:solidFill>
                   <a:srgbClr val="14161C"/>
                 </a:solidFill>
@@ -14430,10 +14474,10 @@
                 <a:ea typeface="Be Vietnam Pro SemiBold" pitchFamily="34" charset="-122"/>
                 <a:cs typeface="Be Vietnam Pro SemiBold" pitchFamily="34" charset="-120"/>
               </a:rPr>
-              <a:t> nhìn</a:t>
-            </a:r>
-            <a:r>
-              <a:rPr lang="en-US" sz="2550" dirty="0" spc="-3" kern="0">
+              <a:t> lõi,</a:t>
+            </a:r>
+            <a:r>
+              <a:rPr lang="en-US" sz="2550" dirty="0" spc="21" kern="0">
                 <a:solidFill>
                   <a:srgbClr val="14161C"/>
                 </a:solidFill>
@@ -14441,10 +14485,10 @@
                 <a:ea typeface="Be Vietnam Pro SemiBold" pitchFamily="34" charset="-122"/>
                 <a:cs typeface="Be Vietnam Pro SemiBold" pitchFamily="34" charset="-120"/>
               </a:rPr>
-              <a:t> cờ</a:t>
-            </a:r>
-            <a:r>
-              <a:rPr lang="en-US" sz="2550" dirty="0" spc="-1" kern="0">
+              <a:t> nhưng</a:t>
+            </a:r>
+            <a:r>
+              <a:rPr lang="en-US" sz="2550" dirty="0" spc="-3" kern="0">
                 <a:solidFill>
                   <a:srgbClr val="14161C"/>
                 </a:solidFill>
@@ -14452,10 +14496,10 @@
                 <a:ea typeface="Be Vietnam Pro SemiBold" pitchFamily="34" charset="-122"/>
                 <a:cs typeface="Be Vietnam Pro SemiBold" pitchFamily="34" charset="-120"/>
               </a:rPr>
-              <a:t> liên</a:t>
-            </a:r>
-            <a:r>
-              <a:rPr lang="en-US" sz="2550" dirty="0" spc="0" kern="0">
+              <a:t> cỡ</a:t>
+            </a:r>
+            <a:r>
+              <a:rPr lang="en-US" sz="2550" dirty="0" spc="-1" kern="0">
                 <a:solidFill>
                   <a:srgbClr val="14161C"/>
                 </a:solidFill>
@@ -14463,7 +14507,51 @@
                 <a:ea typeface="Be Vietnam Pro SemiBold" pitchFamily="34" charset="-122"/>
                 <a:cs typeface="Be Vietnam Pro SemiBold" pitchFamily="34" charset="-120"/>
               </a:rPr>
-              <a:t> tục.</a:t>
+              <a:t> 8</a:t>
+            </a:r>
+            <a:r>
+              <a:rPr lang="en-US" sz="2550" dirty="0" spc="-4" kern="0">
+                <a:solidFill>
+                  <a:srgbClr val="14161C"/>
+                </a:solidFill>
+                <a:latin typeface="Be Vietnam Pro SemiBold" pitchFamily="34" charset="0"/>
+                <a:ea typeface="Be Vietnam Pro SemiBold" pitchFamily="34" charset="-122"/>
+                <a:cs typeface="Be Vietnam Pro SemiBold" pitchFamily="34" charset="-120"/>
+              </a:rPr>
+              <a:t> ms</a:t>
+            </a:r>
+            <a:r>
+              <a:rPr lang="en-US" sz="2550" dirty="0" spc="2" kern="0">
+                <a:solidFill>
+                  <a:srgbClr val="14161C"/>
+                </a:solidFill>
+                <a:latin typeface="Be Vietnam Pro SemiBold" pitchFamily="34" charset="0"/>
+                <a:ea typeface="Be Vietnam Pro SemiBold" pitchFamily="34" charset="-122"/>
+                <a:cs typeface="Be Vietnam Pro SemiBold" pitchFamily="34" charset="-120"/>
+              </a:rPr>
+              <a:t> khi</a:t>
+            </a:r>
+            <a:r>
+              <a:rPr lang="en-US" sz="2550" dirty="0" spc="0" kern="0">
+                <a:solidFill>
+                  <a:srgbClr val="14161C"/>
+                </a:solidFill>
+                <a:latin typeface="Be Vietnam Pro SemiBold" pitchFamily="34" charset="0"/>
+                <a:ea typeface="Be Vietnam Pro SemiBold" pitchFamily="34" charset="-122"/>
+                <a:cs typeface="Be Vietnam Pro SemiBold" pitchFamily="34" charset="-120"/>
+              </a:rPr>
+              <a:t> chung</a:t>
+            </a:r>
+            <a:r>
+              <a:rPr lang="en-US" sz="2550" dirty="0" spc="-3" kern="0">
+                <a:solidFill>
+                  <a:srgbClr val="14161C"/>
+                </a:solidFill>
+                <a:latin typeface="Be Vietnam Pro SemiBold" pitchFamily="34" charset="0"/>
+                <a:ea typeface="Be Vietnam Pro SemiBold" pitchFamily="34" charset="-122"/>
+                <a:cs typeface="Be Vietnam Pro SemiBold" pitchFamily="34" charset="-120"/>
+              </a:rPr>
+              <a:t> lõi.</a:t>
             </a:r>
             <a:endParaRPr lang="en-US" sz="2550" dirty="0"/>
           </a:p>
@@ -15811,6 +15899,17 @@
                 <a:cs typeface="Be Vietnam Pro" pitchFamily="34" charset="-120"/>
               </a:rPr>
               <a:t> hợp:</a:t>
+            </a:r>
+            <a:r>
+              <a:rPr lang="en-US" sz="2550" dirty="0" spc="5" kern="0">
+                <a:solidFill>
+                  <a:srgbClr val="14161C"/>
+                </a:solidFill>
+                <a:latin typeface="Be Vietnam Pro" pitchFamily="34" charset="0"/>
+                <a:ea typeface="Be Vietnam Pro" pitchFamily="34" charset="-122"/>
+                <a:cs typeface="Be Vietnam Pro" pitchFamily="34" charset="-120"/>
+              </a:rPr>
+              <a:t> thường</a:t>
             </a:r>
             <a:r>
               <a:rPr lang="en-US" sz="2550" dirty="0" spc="0" kern="0">

</xml_diff>